<commit_message>
Rodada C: waterfall, Pareto e Gantt com formas, paletas por setor, versão JS completa, guias em inglês
- add_waterfall / add_pareto / add_gantt (formas editáveis) + docs em 04-modelos-de-slides e schema (23 tipos)
- 5 paletas por setor: industria, saude, tecnologia, varejo-servicos, educacao-publico
- pptxgenjs/deckbuilder.js reescrito: todos os 23 modelos, kicker/callout/cabeçalho/logo, paginação, exposure
- README.en.md e 00-guia/como-usar.en.md
- escolha-do-grafico atualizada; exemplos e miniaturas regenerados

Co-Authored-By: Claude Fable 5.1 <noreply@anthropic.com>
</commit_message>
<xml_diff>
--- a/examples/analise-de-processo.pptx
+++ b/examples/analise-de-processo.pptx
@@ -3690,7 +3690,7 @@
                 </a:solidFill>
                 <a:latin typeface="Calibri"/>
               </a:rPr>
-              <a:t>set/2026</a:t>
+              <a:t>set/2026 | Uso interno</a:t>
             </a:r>
           </a:p>
         </p:txBody>
@@ -3905,7 +3905,7 @@
                 </a:solidFill>
                 <a:latin typeface="Calibri"/>
               </a:rPr>
-              <a:t>Fonte: Base de solicitações, mar a set/2026 (n=71)</a:t>
+              <a:t>Fonte: Base de solicitações, mar a set/2026 (n=71)   |   Uso interno</a:t>
             </a:r>
           </a:p>
         </p:txBody>
@@ -5190,7 +5190,7 @@
                 </a:solidFill>
                 <a:latin typeface="Calibri"/>
               </a:rPr>
-              <a:t>Fonte: Base de solicitações (n=71)</a:t>
+              <a:t>Fonte: Base de solicitações (n=71)   |   Uso interno</a:t>
             </a:r>
           </a:p>
         </p:txBody>
@@ -5414,7 +5414,7 @@
       </p:sp>
       <p:graphicFrame>
         <p:nvGraphicFramePr>
-          <p:cNvPr id="14" name="Chart 13"/>
+          <p:cNvPr id="14" name="Chart 13" descr="A melhora recente ainda não prova uma virada sustentável"/>
           <p:cNvGraphicFramePr>
             <a:graphicFrameLocks noGrp="1"/>
           </p:cNvGraphicFramePr>
@@ -5666,8 +5666,8 @@
         </p:nvSpPr>
         <p:spPr>
           <a:xfrm>
-            <a:off x="10817352" y="6217920"/>
-            <a:ext cx="914400" cy="365760"/>
+            <a:off x="457200" y="6217920"/>
+            <a:ext cx="8531352" cy="365760"/>
           </a:xfrm>
           <a:prstGeom prst="rect">
             <a:avLst/>
@@ -5680,6 +5680,41 @@
           </a:bodyPr>
           <a:lstStyle/>
           <a:p>
+            <a:pPr algn="l"/>
+            <a:r>
+              <a:rPr sz="1000" b="0" i="0">
+                <a:solidFill>
+                  <a:srgbClr val="8C8C8C"/>
+                </a:solidFill>
+                <a:latin typeface="Calibri"/>
+              </a:rPr>
+              <a:t>Uso interno</a:t>
+            </a:r>
+          </a:p>
+        </p:txBody>
+      </p:sp>
+      <p:sp>
+        <p:nvSpPr>
+          <p:cNvPr id="7" name="TextBox 6"/>
+          <p:cNvSpPr txBox="1"/>
+          <p:nvPr/>
+        </p:nvSpPr>
+        <p:spPr>
+          <a:xfrm>
+            <a:off x="10817352" y="6217920"/>
+            <a:ext cx="914400" cy="365760"/>
+          </a:xfrm>
+          <a:prstGeom prst="rect">
+            <a:avLst/>
+          </a:prstGeom>
+          <a:noFill/>
+        </p:spPr>
+        <p:txBody>
+          <a:bodyPr wrap="square" anchor="ctr" lIns="45720" rIns="45720" tIns="27432" bIns="27432">
+            <a:spAutoFit/>
+          </a:bodyPr>
+          <a:lstStyle/>
+          <a:p>
             <a:pPr algn="r"/>
             <a:r>
               <a:rPr sz="1000" b="0" i="0">
@@ -5695,7 +5730,7 @@
       </p:sp>
       <p:pic>
         <p:nvPicPr>
-          <p:cNvPr id="7" name="Picture 6" descr="logo-placeholder.png"/>
+          <p:cNvPr id="8" name="Picture 7" descr="logo-placeholder.png"/>
           <p:cNvPicPr>
             <a:picLocks noChangeAspect="1"/>
           </p:cNvPicPr>
@@ -5719,7 +5754,7 @@
       </p:pic>
       <p:sp>
         <p:nvSpPr>
-          <p:cNvPr id="8" name="Rectangle 7"/>
+          <p:cNvPr id="9" name="Rectangle 8"/>
           <p:cNvSpPr/>
           <p:nvPr/>
         </p:nvSpPr>
@@ -5763,7 +5798,7 @@
       </p:sp>
       <p:sp>
         <p:nvSpPr>
-          <p:cNvPr id="9" name="Rectangle 8"/>
+          <p:cNvPr id="10" name="Rectangle 9"/>
           <p:cNvSpPr/>
           <p:nvPr/>
         </p:nvSpPr>
@@ -5807,7 +5842,7 @@
       </p:sp>
       <p:sp>
         <p:nvSpPr>
-          <p:cNvPr id="10" name="TextBox 9"/>
+          <p:cNvPr id="11" name="TextBox 10"/>
           <p:cNvSpPr txBox="1"/>
           <p:nvPr/>
         </p:nvSpPr>
@@ -5842,7 +5877,7 @@
       </p:sp>
       <p:sp>
         <p:nvSpPr>
-          <p:cNvPr id="11" name="TextBox 10"/>
+          <p:cNvPr id="12" name="TextBox 11"/>
           <p:cNvSpPr txBox="1"/>
           <p:nvPr/>
         </p:nvSpPr>
@@ -5877,7 +5912,7 @@
       </p:sp>
       <p:sp>
         <p:nvSpPr>
-          <p:cNvPr id="12" name="Pentagon 11"/>
+          <p:cNvPr id="13" name="Pentagon 12"/>
           <p:cNvSpPr/>
           <p:nvPr/>
         </p:nvSpPr>
@@ -5930,7 +5965,7 @@
       </p:sp>
       <p:sp>
         <p:nvSpPr>
-          <p:cNvPr id="13" name="Chevron 12"/>
+          <p:cNvPr id="14" name="Chevron 13"/>
           <p:cNvSpPr/>
           <p:nvPr/>
         </p:nvSpPr>
@@ -5983,7 +6018,7 @@
       </p:sp>
       <p:sp>
         <p:nvSpPr>
-          <p:cNvPr id="14" name="TextBox 13"/>
+          <p:cNvPr id="15" name="TextBox 14"/>
           <p:cNvSpPr txBox="1"/>
           <p:nvPr/>
         </p:nvSpPr>
@@ -6018,7 +6053,7 @@
       </p:sp>
       <p:sp>
         <p:nvSpPr>
-          <p:cNvPr id="15" name="TextBox 14"/>
+          <p:cNvPr id="16" name="TextBox 15"/>
           <p:cNvSpPr txBox="1"/>
           <p:nvPr/>
         </p:nvSpPr>
@@ -6053,7 +6088,7 @@
       </p:sp>
       <p:sp>
         <p:nvSpPr>
-          <p:cNvPr id="16" name="Chevron 15"/>
+          <p:cNvPr id="17" name="Chevron 16"/>
           <p:cNvSpPr/>
           <p:nvPr/>
         </p:nvSpPr>
@@ -6106,7 +6141,7 @@
       </p:sp>
       <p:sp>
         <p:nvSpPr>
-          <p:cNvPr id="17" name="TextBox 16"/>
+          <p:cNvPr id="18" name="TextBox 17"/>
           <p:cNvSpPr txBox="1"/>
           <p:nvPr/>
         </p:nvSpPr>
@@ -6141,7 +6176,7 @@
       </p:sp>
       <p:sp>
         <p:nvSpPr>
-          <p:cNvPr id="18" name="TextBox 17"/>
+          <p:cNvPr id="19" name="TextBox 18"/>
           <p:cNvSpPr txBox="1"/>
           <p:nvPr/>
         </p:nvSpPr>
@@ -6176,7 +6211,7 @@
       </p:sp>
       <p:sp>
         <p:nvSpPr>
-          <p:cNvPr id="19" name="Chevron 18"/>
+          <p:cNvPr id="20" name="Chevron 19"/>
           <p:cNvSpPr/>
           <p:nvPr/>
         </p:nvSpPr>
@@ -6229,7 +6264,7 @@
       </p:sp>
       <p:sp>
         <p:nvSpPr>
-          <p:cNvPr id="20" name="TextBox 19"/>
+          <p:cNvPr id="21" name="TextBox 20"/>
           <p:cNvSpPr txBox="1"/>
           <p:nvPr/>
         </p:nvSpPr>
@@ -6264,7 +6299,7 @@
       </p:sp>
       <p:sp>
         <p:nvSpPr>
-          <p:cNvPr id="21" name="TextBox 20"/>
+          <p:cNvPr id="22" name="TextBox 21"/>
           <p:cNvSpPr txBox="1"/>
           <p:nvPr/>
         </p:nvSpPr>
@@ -6461,8 +6496,8 @@
         </p:nvSpPr>
         <p:spPr>
           <a:xfrm>
-            <a:off x="10817352" y="6217920"/>
-            <a:ext cx="914400" cy="365760"/>
+            <a:off x="457200" y="6217920"/>
+            <a:ext cx="8531352" cy="365760"/>
           </a:xfrm>
           <a:prstGeom prst="rect">
             <a:avLst/>
@@ -6475,6 +6510,41 @@
           </a:bodyPr>
           <a:lstStyle/>
           <a:p>
+            <a:pPr algn="l"/>
+            <a:r>
+              <a:rPr sz="1000" b="0" i="0">
+                <a:solidFill>
+                  <a:srgbClr val="8C8C8C"/>
+                </a:solidFill>
+                <a:latin typeface="Calibri"/>
+              </a:rPr>
+              <a:t>Uso interno</a:t>
+            </a:r>
+          </a:p>
+        </p:txBody>
+      </p:sp>
+      <p:sp>
+        <p:nvSpPr>
+          <p:cNvPr id="7" name="TextBox 6"/>
+          <p:cNvSpPr txBox="1"/>
+          <p:nvPr/>
+        </p:nvSpPr>
+        <p:spPr>
+          <a:xfrm>
+            <a:off x="10817352" y="6217920"/>
+            <a:ext cx="914400" cy="365760"/>
+          </a:xfrm>
+          <a:prstGeom prst="rect">
+            <a:avLst/>
+          </a:prstGeom>
+          <a:noFill/>
+        </p:spPr>
+        <p:txBody>
+          <a:bodyPr wrap="square" anchor="ctr" lIns="45720" rIns="45720" tIns="27432" bIns="27432">
+            <a:spAutoFit/>
+          </a:bodyPr>
+          <a:lstStyle/>
+          <a:p>
             <a:pPr algn="r"/>
             <a:r>
               <a:rPr sz="1000" b="0" i="0">
@@ -6490,7 +6560,7 @@
       </p:sp>
       <p:pic>
         <p:nvPicPr>
-          <p:cNvPr id="7" name="Picture 6" descr="logo-placeholder.png"/>
+          <p:cNvPr id="8" name="Picture 7" descr="logo-placeholder.png"/>
           <p:cNvPicPr>
             <a:picLocks noChangeAspect="1"/>
           </p:cNvPicPr>
@@ -6514,7 +6584,7 @@
       </p:pic>
       <p:sp>
         <p:nvSpPr>
-          <p:cNvPr id="8" name="Rectangle 7"/>
+          <p:cNvPr id="9" name="Rectangle 8"/>
           <p:cNvSpPr/>
           <p:nvPr/>
         </p:nvSpPr>
@@ -6558,7 +6628,7 @@
       </p:sp>
       <p:sp>
         <p:nvSpPr>
-          <p:cNvPr id="9" name="TextBox 8"/>
+          <p:cNvPr id="10" name="TextBox 9"/>
           <p:cNvSpPr txBox="1"/>
           <p:nvPr/>
         </p:nvSpPr>
@@ -6593,7 +6663,7 @@
       </p:sp>
       <p:sp>
         <p:nvSpPr>
-          <p:cNvPr id="10" name="TextBox 9"/>
+          <p:cNvPr id="11" name="TextBox 10"/>
           <p:cNvSpPr txBox="1"/>
           <p:nvPr/>
         </p:nvSpPr>
@@ -6628,7 +6698,7 @@
       </p:sp>
       <p:sp>
         <p:nvSpPr>
-          <p:cNvPr id="11" name="TextBox 10"/>
+          <p:cNvPr id="12" name="TextBox 11"/>
           <p:cNvSpPr txBox="1"/>
           <p:nvPr/>
         </p:nvSpPr>
@@ -6663,7 +6733,7 @@
       </p:sp>
       <p:sp>
         <p:nvSpPr>
-          <p:cNvPr id="12" name="Rectangle 11"/>
+          <p:cNvPr id="13" name="Rectangle 12"/>
           <p:cNvSpPr/>
           <p:nvPr/>
         </p:nvSpPr>
@@ -6707,7 +6777,7 @@
       </p:sp>
       <p:sp>
         <p:nvSpPr>
-          <p:cNvPr id="13" name="Rectangle 12"/>
+          <p:cNvPr id="14" name="Rectangle 13"/>
           <p:cNvSpPr/>
           <p:nvPr/>
         </p:nvSpPr>
@@ -6751,7 +6821,7 @@
       </p:sp>
       <p:sp>
         <p:nvSpPr>
-          <p:cNvPr id="14" name="TextBox 13"/>
+          <p:cNvPr id="15" name="TextBox 14"/>
           <p:cNvSpPr txBox="1"/>
           <p:nvPr/>
         </p:nvSpPr>
@@ -6786,7 +6856,7 @@
       </p:sp>
       <p:sp>
         <p:nvSpPr>
-          <p:cNvPr id="15" name="TextBox 14"/>
+          <p:cNvPr id="16" name="TextBox 15"/>
           <p:cNvSpPr txBox="1"/>
           <p:nvPr/>
         </p:nvSpPr>
@@ -6821,7 +6891,7 @@
       </p:sp>
       <p:sp>
         <p:nvSpPr>
-          <p:cNvPr id="16" name="Rectangle 15"/>
+          <p:cNvPr id="17" name="Rectangle 16"/>
           <p:cNvSpPr/>
           <p:nvPr/>
         </p:nvSpPr>
@@ -6865,7 +6935,7 @@
       </p:sp>
       <p:sp>
         <p:nvSpPr>
-          <p:cNvPr id="17" name="Rectangle 16"/>
+          <p:cNvPr id="18" name="Rectangle 17"/>
           <p:cNvSpPr/>
           <p:nvPr/>
         </p:nvSpPr>
@@ -6909,7 +6979,7 @@
       </p:sp>
       <p:sp>
         <p:nvSpPr>
-          <p:cNvPr id="18" name="TextBox 17"/>
+          <p:cNvPr id="19" name="TextBox 18"/>
           <p:cNvSpPr txBox="1"/>
           <p:nvPr/>
         </p:nvSpPr>
@@ -6944,7 +7014,7 @@
       </p:sp>
       <p:sp>
         <p:nvSpPr>
-          <p:cNvPr id="19" name="TextBox 18"/>
+          <p:cNvPr id="20" name="TextBox 19"/>
           <p:cNvSpPr txBox="1"/>
           <p:nvPr/>
         </p:nvSpPr>
@@ -6979,7 +7049,7 @@
       </p:sp>
       <p:sp>
         <p:nvSpPr>
-          <p:cNvPr id="20" name="Rectangle 19"/>
+          <p:cNvPr id="21" name="Rectangle 20"/>
           <p:cNvSpPr/>
           <p:nvPr/>
         </p:nvSpPr>
@@ -7023,7 +7093,7 @@
       </p:sp>
       <p:sp>
         <p:nvSpPr>
-          <p:cNvPr id="21" name="Rectangle 20"/>
+          <p:cNvPr id="22" name="Rectangle 21"/>
           <p:cNvSpPr/>
           <p:nvPr/>
         </p:nvSpPr>
@@ -7067,7 +7137,7 @@
       </p:sp>
       <p:sp>
         <p:nvSpPr>
-          <p:cNvPr id="22" name="TextBox 21"/>
+          <p:cNvPr id="23" name="TextBox 22"/>
           <p:cNvSpPr txBox="1"/>
           <p:nvPr/>
         </p:nvSpPr>
@@ -7102,7 +7172,7 @@
       </p:sp>
       <p:sp>
         <p:nvSpPr>
-          <p:cNvPr id="23" name="TextBox 22"/>
+          <p:cNvPr id="24" name="TextBox 23"/>
           <p:cNvSpPr txBox="1"/>
           <p:nvPr/>
         </p:nvSpPr>
@@ -7137,7 +7207,7 @@
       </p:sp>
       <p:sp>
         <p:nvSpPr>
-          <p:cNvPr id="24" name="Rectangle 23"/>
+          <p:cNvPr id="25" name="Rectangle 24"/>
           <p:cNvSpPr/>
           <p:nvPr/>
         </p:nvSpPr>
@@ -7181,7 +7251,7 @@
       </p:sp>
       <p:sp>
         <p:nvSpPr>
-          <p:cNvPr id="25" name="Rectangle 24"/>
+          <p:cNvPr id="26" name="Rectangle 25"/>
           <p:cNvSpPr/>
           <p:nvPr/>
         </p:nvSpPr>
@@ -7225,7 +7295,7 @@
       </p:sp>
       <p:sp>
         <p:nvSpPr>
-          <p:cNvPr id="26" name="TextBox 25"/>
+          <p:cNvPr id="27" name="TextBox 26"/>
           <p:cNvSpPr txBox="1"/>
           <p:nvPr/>
         </p:nvSpPr>
@@ -7422,8 +7492,8 @@
         </p:nvSpPr>
         <p:spPr>
           <a:xfrm>
-            <a:off x="10817352" y="6217920"/>
-            <a:ext cx="914400" cy="365760"/>
+            <a:off x="457200" y="6217920"/>
+            <a:ext cx="8531352" cy="365760"/>
           </a:xfrm>
           <a:prstGeom prst="rect">
             <a:avLst/>
@@ -7436,6 +7506,41 @@
           </a:bodyPr>
           <a:lstStyle/>
           <a:p>
+            <a:pPr algn="l"/>
+            <a:r>
+              <a:rPr sz="1000" b="0" i="0">
+                <a:solidFill>
+                  <a:srgbClr val="8C8C8C"/>
+                </a:solidFill>
+                <a:latin typeface="Calibri"/>
+              </a:rPr>
+              <a:t>Uso interno</a:t>
+            </a:r>
+          </a:p>
+        </p:txBody>
+      </p:sp>
+      <p:sp>
+        <p:nvSpPr>
+          <p:cNvPr id="7" name="TextBox 6"/>
+          <p:cNvSpPr txBox="1"/>
+          <p:nvPr/>
+        </p:nvSpPr>
+        <p:spPr>
+          <a:xfrm>
+            <a:off x="10817352" y="6217920"/>
+            <a:ext cx="914400" cy="365760"/>
+          </a:xfrm>
+          <a:prstGeom prst="rect">
+            <a:avLst/>
+          </a:prstGeom>
+          <a:noFill/>
+        </p:spPr>
+        <p:txBody>
+          <a:bodyPr wrap="square" anchor="ctr" lIns="45720" rIns="45720" tIns="27432" bIns="27432">
+            <a:spAutoFit/>
+          </a:bodyPr>
+          <a:lstStyle/>
+          <a:p>
             <a:pPr algn="r"/>
             <a:r>
               <a:rPr sz="1000" b="0" i="0">
@@ -7451,7 +7556,7 @@
       </p:sp>
       <p:pic>
         <p:nvPicPr>
-          <p:cNvPr id="7" name="Picture 6" descr="logo-placeholder.png"/>
+          <p:cNvPr id="8" name="Picture 7" descr="logo-placeholder.png"/>
           <p:cNvPicPr>
             <a:picLocks noChangeAspect="1"/>
           </p:cNvPicPr>
@@ -7475,7 +7580,7 @@
       </p:pic>
       <p:sp>
         <p:nvSpPr>
-          <p:cNvPr id="8" name="Rectangle 7"/>
+          <p:cNvPr id="9" name="Rectangle 8"/>
           <p:cNvSpPr/>
           <p:nvPr/>
         </p:nvSpPr>
@@ -7519,7 +7624,7 @@
       </p:sp>
       <p:sp>
         <p:nvSpPr>
-          <p:cNvPr id="9" name="TextBox 8"/>
+          <p:cNvPr id="10" name="TextBox 9"/>
           <p:cNvSpPr txBox="1"/>
           <p:nvPr/>
         </p:nvSpPr>
@@ -7554,7 +7659,7 @@
       </p:sp>
       <p:sp>
         <p:nvSpPr>
-          <p:cNvPr id="10" name="TextBox 9"/>
+          <p:cNvPr id="11" name="TextBox 10"/>
           <p:cNvSpPr txBox="1"/>
           <p:nvPr/>
         </p:nvSpPr>
@@ -7589,7 +7694,7 @@
       </p:sp>
       <p:sp>
         <p:nvSpPr>
-          <p:cNvPr id="11" name="Rectangle 10"/>
+          <p:cNvPr id="12" name="Rectangle 11"/>
           <p:cNvSpPr/>
           <p:nvPr/>
         </p:nvSpPr>
@@ -7633,7 +7738,7 @@
       </p:sp>
       <p:sp>
         <p:nvSpPr>
-          <p:cNvPr id="12" name="Rectangle 11"/>
+          <p:cNvPr id="13" name="Rectangle 12"/>
           <p:cNvSpPr/>
           <p:nvPr/>
         </p:nvSpPr>
@@ -7677,7 +7782,7 @@
       </p:sp>
       <p:sp>
         <p:nvSpPr>
-          <p:cNvPr id="13" name="Rectangle 12"/>
+          <p:cNvPr id="14" name="Rectangle 13"/>
           <p:cNvSpPr/>
           <p:nvPr/>
         </p:nvSpPr>
@@ -7721,7 +7826,7 @@
       </p:sp>
       <p:sp>
         <p:nvSpPr>
-          <p:cNvPr id="14" name="TextBox 13"/>
+          <p:cNvPr id="15" name="TextBox 14"/>
           <p:cNvSpPr txBox="1"/>
           <p:nvPr/>
         </p:nvSpPr>
@@ -7756,7 +7861,7 @@
       </p:sp>
       <p:sp>
         <p:nvSpPr>
-          <p:cNvPr id="15" name="TextBox 14"/>
+          <p:cNvPr id="16" name="TextBox 15"/>
           <p:cNvSpPr txBox="1"/>
           <p:nvPr/>
         </p:nvSpPr>
@@ -7791,7 +7896,7 @@
       </p:sp>
       <p:sp>
         <p:nvSpPr>
-          <p:cNvPr id="16" name="TextBox 15"/>
+          <p:cNvPr id="17" name="TextBox 16"/>
           <p:cNvSpPr txBox="1"/>
           <p:nvPr/>
         </p:nvSpPr>
@@ -7826,7 +7931,7 @@
       </p:sp>
       <p:sp>
         <p:nvSpPr>
-          <p:cNvPr id="17" name="Rectangle 16"/>
+          <p:cNvPr id="18" name="Rectangle 17"/>
           <p:cNvSpPr/>
           <p:nvPr/>
         </p:nvSpPr>
@@ -7870,7 +7975,7 @@
       </p:sp>
       <p:sp>
         <p:nvSpPr>
-          <p:cNvPr id="18" name="Rectangle 17"/>
+          <p:cNvPr id="19" name="Rectangle 18"/>
           <p:cNvSpPr/>
           <p:nvPr/>
         </p:nvSpPr>
@@ -7914,7 +8019,7 @@
       </p:sp>
       <p:sp>
         <p:nvSpPr>
-          <p:cNvPr id="19" name="Rectangle 18"/>
+          <p:cNvPr id="20" name="Rectangle 19"/>
           <p:cNvSpPr/>
           <p:nvPr/>
         </p:nvSpPr>
@@ -7958,7 +8063,7 @@
       </p:sp>
       <p:sp>
         <p:nvSpPr>
-          <p:cNvPr id="20" name="TextBox 19"/>
+          <p:cNvPr id="21" name="TextBox 20"/>
           <p:cNvSpPr txBox="1"/>
           <p:nvPr/>
         </p:nvSpPr>
@@ -7993,7 +8098,7 @@
       </p:sp>
       <p:sp>
         <p:nvSpPr>
-          <p:cNvPr id="21" name="TextBox 20"/>
+          <p:cNvPr id="22" name="TextBox 21"/>
           <p:cNvSpPr txBox="1"/>
           <p:nvPr/>
         </p:nvSpPr>
@@ -8028,7 +8133,7 @@
       </p:sp>
       <p:sp>
         <p:nvSpPr>
-          <p:cNvPr id="22" name="TextBox 21"/>
+          <p:cNvPr id="23" name="TextBox 22"/>
           <p:cNvSpPr txBox="1"/>
           <p:nvPr/>
         </p:nvSpPr>
@@ -8063,7 +8168,7 @@
       </p:sp>
       <p:sp>
         <p:nvSpPr>
-          <p:cNvPr id="23" name="Rectangle 22"/>
+          <p:cNvPr id="24" name="Rectangle 23"/>
           <p:cNvSpPr/>
           <p:nvPr/>
         </p:nvSpPr>
@@ -8107,7 +8212,7 @@
       </p:sp>
       <p:sp>
         <p:nvSpPr>
-          <p:cNvPr id="24" name="Rectangle 23"/>
+          <p:cNvPr id="25" name="Rectangle 24"/>
           <p:cNvSpPr/>
           <p:nvPr/>
         </p:nvSpPr>
@@ -8151,7 +8256,7 @@
       </p:sp>
       <p:sp>
         <p:nvSpPr>
-          <p:cNvPr id="25" name="Rectangle 24"/>
+          <p:cNvPr id="26" name="Rectangle 25"/>
           <p:cNvSpPr/>
           <p:nvPr/>
         </p:nvSpPr>
@@ -8195,7 +8300,7 @@
       </p:sp>
       <p:sp>
         <p:nvSpPr>
-          <p:cNvPr id="26" name="TextBox 25"/>
+          <p:cNvPr id="27" name="TextBox 26"/>
           <p:cNvSpPr txBox="1"/>
           <p:nvPr/>
         </p:nvSpPr>
@@ -8230,7 +8335,7 @@
       </p:sp>
       <p:sp>
         <p:nvSpPr>
-          <p:cNvPr id="27" name="TextBox 26"/>
+          <p:cNvPr id="28" name="TextBox 27"/>
           <p:cNvSpPr txBox="1"/>
           <p:nvPr/>
         </p:nvSpPr>
@@ -8265,7 +8370,7 @@
       </p:sp>
       <p:sp>
         <p:nvSpPr>
-          <p:cNvPr id="28" name="TextBox 27"/>
+          <p:cNvPr id="29" name="TextBox 28"/>
           <p:cNvSpPr txBox="1"/>
           <p:nvPr/>
         </p:nvSpPr>

</xml_diff>